<commit_message>
Add presentation and test report for phase 3; update SQL scripts for CDC process
</commit_message>
<xml_diff>
--- a/inleveren fase 3/Fase 3 -  Presentatie 1.0.pptx
+++ b/inleveren fase 3/Fase 3 -  Presentatie 1.0.pptx
@@ -203,7 +203,7 @@
 <file path=ppt/revisionInfo.xml><?xml version="1.0" encoding="utf-8"?>
 <p1510:revInfo xmlns:a="http://schemas.openxmlformats.org/drawingml/2006/main" xmlns:r="http://schemas.openxmlformats.org/officeDocument/2006/relationships" xmlns:p1510="http://schemas.microsoft.com/office/powerpoint/2015/10/main">
   <p1510:revLst>
-    <p1510:client id="{EC454FDF-997F-474F-86A4-FCF145B2228E}" v="162" dt="2026-04-02T14:05:56.342"/>
+    <p1510:client id="{EC454FDF-997F-474F-86A4-FCF145B2228E}" v="166" dt="2026-04-04T11:02:52.249"/>
   </p1510:revLst>
 </p1510:revInfo>
 </file>
@@ -213,7 +213,7 @@
   <pc:docChgLst>
     <pc:chgData name="Meijden, William van der" userId="936082d1-b391-4831-9b18-969e6ea4140e" providerId="ADAL" clId="{A51E778C-228C-4BFD-BA5F-D56B1B5A0CD4}"/>
     <pc:docChg chg="undo redo custSel addSld delSld modSld sldOrd addSection modSection">
-      <pc:chgData name="Meijden, William van der" userId="936082d1-b391-4831-9b18-969e6ea4140e" providerId="ADAL" clId="{A51E778C-228C-4BFD-BA5F-D56B1B5A0CD4}" dt="2026-04-04T10:10:51.175" v="48954" actId="20577"/>
+      <pc:chgData name="Meijden, William van der" userId="936082d1-b391-4831-9b18-969e6ea4140e" providerId="ADAL" clId="{A51E778C-228C-4BFD-BA5F-D56B1B5A0CD4}" dt="2026-04-04T11:03:05.793" v="48961" actId="1076"/>
       <pc:docMkLst>
         <pc:docMk/>
       </pc:docMkLst>
@@ -527,7 +527,7 @@
         </pc:cxnChg>
       </pc:sldChg>
       <pc:sldChg chg="addSp delSp modSp add mod ord modNotesTx">
-        <pc:chgData name="Meijden, William van der" userId="936082d1-b391-4831-9b18-969e6ea4140e" providerId="ADAL" clId="{A51E778C-228C-4BFD-BA5F-D56B1B5A0CD4}" dt="2026-04-04T10:09:16.470" v="48870" actId="20577"/>
+        <pc:chgData name="Meijden, William van der" userId="936082d1-b391-4831-9b18-969e6ea4140e" providerId="ADAL" clId="{A51E778C-228C-4BFD-BA5F-D56B1B5A0CD4}" dt="2026-04-04T11:03:05.793" v="48961" actId="1076"/>
         <pc:sldMkLst>
           <pc:docMk/>
           <pc:sldMk cId="691245667" sldId="313"/>
@@ -541,7 +541,7 @@
           </ac:spMkLst>
         </pc:spChg>
         <pc:spChg chg="add del mod">
-          <ac:chgData name="Meijden, William van der" userId="936082d1-b391-4831-9b18-969e6ea4140e" providerId="ADAL" clId="{A51E778C-228C-4BFD-BA5F-D56B1B5A0CD4}" dt="2026-04-04T10:09:16.470" v="48870" actId="20577"/>
+          <ac:chgData name="Meijden, William van der" userId="936082d1-b391-4831-9b18-969e6ea4140e" providerId="ADAL" clId="{A51E778C-228C-4BFD-BA5F-D56B1B5A0CD4}" dt="2026-04-04T11:02:57.607" v="48960" actId="27636"/>
           <ac:spMkLst>
             <pc:docMk/>
             <pc:sldMk cId="691245667" sldId="313"/>
@@ -556,6 +556,22 @@
             <ac:spMk id="5" creationId="{13DD3154-1D0D-9DCA-6A78-5DDADE4B1475}"/>
           </ac:spMkLst>
         </pc:spChg>
+        <pc:spChg chg="add del mod">
+          <ac:chgData name="Meijden, William van der" userId="936082d1-b391-4831-9b18-969e6ea4140e" providerId="ADAL" clId="{A51E778C-228C-4BFD-BA5F-D56B1B5A0CD4}" dt="2026-04-04T11:02:52.249" v="48958" actId="478"/>
+          <ac:spMkLst>
+            <pc:docMk/>
+            <pc:sldMk cId="691245667" sldId="313"/>
+            <ac:spMk id="8" creationId="{D89C3655-380E-3DB1-6DDB-66DFE888968B}"/>
+          </ac:spMkLst>
+        </pc:spChg>
+        <pc:graphicFrameChg chg="add mod">
+          <ac:chgData name="Meijden, William van der" userId="936082d1-b391-4831-9b18-969e6ea4140e" providerId="ADAL" clId="{A51E778C-228C-4BFD-BA5F-D56B1B5A0CD4}" dt="2026-04-04T11:03:05.793" v="48961" actId="1076"/>
+          <ac:graphicFrameMkLst>
+            <pc:docMk/>
+            <pc:sldMk cId="691245667" sldId="313"/>
+            <ac:graphicFrameMk id="7" creationId="{088395C5-7A2D-EA1D-563D-B2BC78D79954}"/>
+          </ac:graphicFrameMkLst>
+        </pc:graphicFrameChg>
         <pc:picChg chg="add mod">
           <ac:chgData name="Meijden, William van der" userId="936082d1-b391-4831-9b18-969e6ea4140e" providerId="ADAL" clId="{A51E778C-228C-4BFD-BA5F-D56B1B5A0CD4}" dt="2026-03-31T09:47:36.351" v="44974" actId="1076"/>
           <ac:picMkLst>
@@ -21508,12 +21524,12 @@
         <p:spPr>
           <a:xfrm>
             <a:off x="838200" y="1825625"/>
-            <a:ext cx="6845401" cy="4351338"/>
+            <a:ext cx="6845401" cy="1840230"/>
           </a:xfrm>
         </p:spPr>
         <p:txBody>
           <a:bodyPr>
-            <a:normAutofit/>
+            <a:normAutofit fontScale="92500" lnSpcReduction="10000"/>
           </a:bodyPr>
           <a:lstStyle/>
           <a:p>
@@ -21656,6 +21672,626 @@
           </a:prstGeom>
         </p:spPr>
       </p:pic>
+      <p:graphicFrame>
+        <p:nvGraphicFramePr>
+          <p:cNvPr id="7" name="Table 6">
+            <a:extLst>
+              <a:ext uri="{FF2B5EF4-FFF2-40B4-BE49-F238E27FC236}">
+                <a16:creationId xmlns:a16="http://schemas.microsoft.com/office/drawing/2014/main" id="{088395C5-7A2D-EA1D-563D-B2BC78D79954}"/>
+              </a:ext>
+            </a:extLst>
+          </p:cNvPr>
+          <p:cNvGraphicFramePr>
+            <a:graphicFrameLocks noGrp="1"/>
+          </p:cNvGraphicFramePr>
+          <p:nvPr>
+            <p:extLst>
+              <p:ext uri="{D42A27DB-BD31-4B8C-83A1-F6EECF244321}">
+                <p14:modId xmlns:p14="http://schemas.microsoft.com/office/powerpoint/2010/main" val="1422008474"/>
+              </p:ext>
+            </p:extLst>
+          </p:nvPr>
+        </p:nvGraphicFramePr>
+        <p:xfrm>
+          <a:off x="651505" y="4028193"/>
+          <a:ext cx="7072364" cy="2692908"/>
+        </p:xfrm>
+        <a:graphic>
+          <a:graphicData uri="http://schemas.openxmlformats.org/drawingml/2006/table">
+            <a:tbl>
+              <a:tblPr firstRow="1" firstCol="1" bandRow="1">
+                <a:tableStyleId>{5C22544A-7EE6-4342-B048-85BDC9FD1C3A}</a:tableStyleId>
+              </a:tblPr>
+              <a:tblGrid>
+                <a:gridCol w="1768091">
+                  <a:extLst>
+                    <a:ext uri="{9D8B030D-6E8A-4147-A177-3AD203B41FA5}">
+                      <a16:colId xmlns:a16="http://schemas.microsoft.com/office/drawing/2014/main" val="1657446010"/>
+                    </a:ext>
+                  </a:extLst>
+                </a:gridCol>
+                <a:gridCol w="1768091">
+                  <a:extLst>
+                    <a:ext uri="{9D8B030D-6E8A-4147-A177-3AD203B41FA5}">
+                      <a16:colId xmlns:a16="http://schemas.microsoft.com/office/drawing/2014/main" val="2511471216"/>
+                    </a:ext>
+                  </a:extLst>
+                </a:gridCol>
+                <a:gridCol w="1768091">
+                  <a:extLst>
+                    <a:ext uri="{9D8B030D-6E8A-4147-A177-3AD203B41FA5}">
+                      <a16:colId xmlns:a16="http://schemas.microsoft.com/office/drawing/2014/main" val="1605143898"/>
+                    </a:ext>
+                  </a:extLst>
+                </a:gridCol>
+                <a:gridCol w="1768091">
+                  <a:extLst>
+                    <a:ext uri="{9D8B030D-6E8A-4147-A177-3AD203B41FA5}">
+                      <a16:colId xmlns:a16="http://schemas.microsoft.com/office/drawing/2014/main" val="658604724"/>
+                    </a:ext>
+                  </a:extLst>
+                </a:gridCol>
+              </a:tblGrid>
+              <a:tr h="0">
+                <a:tc>
+                  <a:txBody>
+                    <a:bodyPr/>
+                    <a:lstStyle/>
+                    <a:p>
+                      <a:pPr algn="l">
+                        <a:lnSpc>
+                          <a:spcPct val="120000"/>
+                        </a:lnSpc>
+                        <a:spcAft>
+                          <a:spcPts val="1200"/>
+                        </a:spcAft>
+                        <a:buNone/>
+                      </a:pPr>
+                      <a:r>
+                        <a:rPr lang="nl-NL" sz="1000" spc="-10">
+                          <a:effectLst/>
+                        </a:rPr>
+                        <a:t>Dimensie</a:t>
+                      </a:r>
+                      <a:endParaRPr lang="en-NL" sz="1000" spc="-10">
+                        <a:solidFill>
+                          <a:srgbClr val="3B3B3B"/>
+                        </a:solidFill>
+                        <a:effectLst/>
+                        <a:latin typeface="Ubuntu Light" panose="020B0304030602030204" pitchFamily="34" charset="0"/>
+                        <a:ea typeface="Arial" panose="020B0604020202020204" pitchFamily="34" charset="0"/>
+                        <a:cs typeface="Times New Roman" panose="02020603050405020304" pitchFamily="18" charset="0"/>
+                      </a:endParaRPr>
+                    </a:p>
+                  </a:txBody>
+                  <a:tcPr marL="68580" marR="68580" marT="68580" marB="68580" anchor="ctr"/>
+                </a:tc>
+                <a:tc>
+                  <a:txBody>
+                    <a:bodyPr/>
+                    <a:lstStyle/>
+                    <a:p>
+                      <a:pPr algn="l">
+                        <a:lnSpc>
+                          <a:spcPct val="120000"/>
+                        </a:lnSpc>
+                        <a:spcAft>
+                          <a:spcPts val="1200"/>
+                        </a:spcAft>
+                        <a:buNone/>
+                      </a:pPr>
+                      <a:r>
+                        <a:rPr lang="nl-NL" sz="1000" spc="-10">
+                          <a:effectLst/>
+                        </a:rPr>
+                        <a:t>Betekenis</a:t>
+                      </a:r>
+                      <a:endParaRPr lang="en-NL" sz="1000" spc="-10">
+                        <a:solidFill>
+                          <a:srgbClr val="3B3B3B"/>
+                        </a:solidFill>
+                        <a:effectLst/>
+                        <a:latin typeface="Ubuntu Light" panose="020B0304030602030204" pitchFamily="34" charset="0"/>
+                        <a:ea typeface="Arial" panose="020B0604020202020204" pitchFamily="34" charset="0"/>
+                        <a:cs typeface="Times New Roman" panose="02020603050405020304" pitchFamily="18" charset="0"/>
+                      </a:endParaRPr>
+                    </a:p>
+                  </a:txBody>
+                  <a:tcPr marL="68580" marR="68580" marT="68580" marB="68580" anchor="ctr"/>
+                </a:tc>
+                <a:tc>
+                  <a:txBody>
+                    <a:bodyPr/>
+                    <a:lstStyle/>
+                    <a:p>
+                      <a:pPr algn="l">
+                        <a:lnSpc>
+                          <a:spcPct val="120000"/>
+                        </a:lnSpc>
+                        <a:spcAft>
+                          <a:spcPts val="1200"/>
+                        </a:spcAft>
+                        <a:buNone/>
+                      </a:pPr>
+                      <a:r>
+                        <a:rPr lang="nl-NL" sz="1000" spc="-10">
+                          <a:effectLst/>
+                        </a:rPr>
+                        <a:t>Waarom belangrijk voor dit CDC component</a:t>
+                      </a:r>
+                      <a:endParaRPr lang="en-NL" sz="1000" spc="-10">
+                        <a:solidFill>
+                          <a:srgbClr val="3B3B3B"/>
+                        </a:solidFill>
+                        <a:effectLst/>
+                        <a:latin typeface="Ubuntu Light" panose="020B0304030602030204" pitchFamily="34" charset="0"/>
+                        <a:ea typeface="Arial" panose="020B0604020202020204" pitchFamily="34" charset="0"/>
+                        <a:cs typeface="Times New Roman" panose="02020603050405020304" pitchFamily="18" charset="0"/>
+                      </a:endParaRPr>
+                    </a:p>
+                  </a:txBody>
+                  <a:tcPr marL="68580" marR="68580" marT="68580" marB="68580" anchor="ctr"/>
+                </a:tc>
+                <a:tc>
+                  <a:txBody>
+                    <a:bodyPr/>
+                    <a:lstStyle/>
+                    <a:p>
+                      <a:pPr algn="l">
+                        <a:lnSpc>
+                          <a:spcPct val="120000"/>
+                        </a:lnSpc>
+                        <a:spcAft>
+                          <a:spcPts val="1200"/>
+                        </a:spcAft>
+                        <a:buNone/>
+                      </a:pPr>
+                      <a:r>
+                        <a:rPr lang="nl-NL" sz="1000" spc="-10" dirty="0">
+                          <a:effectLst/>
+                        </a:rPr>
+                        <a:t>Hoe getest</a:t>
+                      </a:r>
+                      <a:endParaRPr lang="en-NL" sz="1000" spc="-10" dirty="0">
+                        <a:solidFill>
+                          <a:srgbClr val="3B3B3B"/>
+                        </a:solidFill>
+                        <a:effectLst/>
+                        <a:latin typeface="Ubuntu Light" panose="020B0304030602030204" pitchFamily="34" charset="0"/>
+                        <a:ea typeface="Arial" panose="020B0604020202020204" pitchFamily="34" charset="0"/>
+                        <a:cs typeface="Times New Roman" panose="02020603050405020304" pitchFamily="18" charset="0"/>
+                      </a:endParaRPr>
+                    </a:p>
+                  </a:txBody>
+                  <a:tcPr marL="68580" marR="68580" marT="68580" marB="68580" anchor="ctr"/>
+                </a:tc>
+                <a:extLst>
+                  <a:ext uri="{0D108BD9-81ED-4DB2-BD59-A6C34878D82A}">
+                    <a16:rowId xmlns:a16="http://schemas.microsoft.com/office/drawing/2014/main" val="3580304340"/>
+                  </a:ext>
+                </a:extLst>
+              </a:tr>
+              <a:tr h="0">
+                <a:tc>
+                  <a:txBody>
+                    <a:bodyPr/>
+                    <a:lstStyle/>
+                    <a:p>
+                      <a:pPr algn="l">
+                        <a:lnSpc>
+                          <a:spcPct val="120000"/>
+                        </a:lnSpc>
+                        <a:spcAft>
+                          <a:spcPts val="1200"/>
+                        </a:spcAft>
+                        <a:buNone/>
+                      </a:pPr>
+                      <a:r>
+                        <a:rPr lang="nl-NL" sz="1000" spc="-10">
+                          <a:effectLst/>
+                        </a:rPr>
+                        <a:t>Completeness</a:t>
+                      </a:r>
+                      <a:endParaRPr lang="en-NL" sz="1000" spc="-10">
+                        <a:solidFill>
+                          <a:srgbClr val="3B3B3B"/>
+                        </a:solidFill>
+                        <a:effectLst/>
+                        <a:latin typeface="Ubuntu Light" panose="020B0304030602030204" pitchFamily="34" charset="0"/>
+                        <a:ea typeface="Arial" panose="020B0604020202020204" pitchFamily="34" charset="0"/>
+                        <a:cs typeface="Times New Roman" panose="02020603050405020304" pitchFamily="18" charset="0"/>
+                      </a:endParaRPr>
+                    </a:p>
+                  </a:txBody>
+                  <a:tcPr marL="68580" marR="68580" marT="68580" marB="68580" anchor="ctr"/>
+                </a:tc>
+                <a:tc>
+                  <a:txBody>
+                    <a:bodyPr/>
+                    <a:lstStyle/>
+                    <a:p>
+                      <a:pPr algn="l">
+                        <a:lnSpc>
+                          <a:spcPct val="120000"/>
+                        </a:lnSpc>
+                        <a:spcAft>
+                          <a:spcPts val="1200"/>
+                        </a:spcAft>
+                        <a:buNone/>
+                      </a:pPr>
+                      <a:r>
+                        <a:rPr lang="nl-NL" sz="1000" spc="-10">
+                          <a:effectLst/>
+                        </a:rPr>
+                        <a:t>Is alle data aanwezig?</a:t>
+                      </a:r>
+                      <a:endParaRPr lang="en-NL" sz="1000" spc="-10">
+                        <a:solidFill>
+                          <a:srgbClr val="3B3B3B"/>
+                        </a:solidFill>
+                        <a:effectLst/>
+                        <a:latin typeface="Ubuntu Light" panose="020B0304030602030204" pitchFamily="34" charset="0"/>
+                        <a:ea typeface="Arial" panose="020B0604020202020204" pitchFamily="34" charset="0"/>
+                        <a:cs typeface="Times New Roman" panose="02020603050405020304" pitchFamily="18" charset="0"/>
+                      </a:endParaRPr>
+                    </a:p>
+                  </a:txBody>
+                  <a:tcPr marL="68580" marR="68580" marT="68580" marB="68580" anchor="ctr"/>
+                </a:tc>
+                <a:tc>
+                  <a:txBody>
+                    <a:bodyPr/>
+                    <a:lstStyle/>
+                    <a:p>
+                      <a:pPr algn="l">
+                        <a:lnSpc>
+                          <a:spcPct val="120000"/>
+                        </a:lnSpc>
+                        <a:spcAft>
+                          <a:spcPts val="1200"/>
+                        </a:spcAft>
+                        <a:buNone/>
+                      </a:pPr>
+                      <a:r>
+                        <a:rPr lang="nl-NL" sz="1000" spc="-10">
+                          <a:effectLst/>
+                        </a:rPr>
+                        <a:t>Het component moet alle (valide) rijen correct overnemen van staging naar target.</a:t>
+                      </a:r>
+                      <a:endParaRPr lang="en-NL" sz="1000" spc="-10">
+                        <a:solidFill>
+                          <a:srgbClr val="3B3B3B"/>
+                        </a:solidFill>
+                        <a:effectLst/>
+                        <a:latin typeface="Ubuntu Light" panose="020B0304030602030204" pitchFamily="34" charset="0"/>
+                        <a:ea typeface="Arial" panose="020B0604020202020204" pitchFamily="34" charset="0"/>
+                        <a:cs typeface="Times New Roman" panose="02020603050405020304" pitchFamily="18" charset="0"/>
+                      </a:endParaRPr>
+                    </a:p>
+                  </a:txBody>
+                  <a:tcPr marL="68580" marR="68580" marT="68580" marB="68580" anchor="ctr"/>
+                </a:tc>
+                <a:tc>
+                  <a:txBody>
+                    <a:bodyPr/>
+                    <a:lstStyle/>
+                    <a:p>
+                      <a:pPr algn="l">
+                        <a:lnSpc>
+                          <a:spcPct val="120000"/>
+                        </a:lnSpc>
+                        <a:spcAft>
+                          <a:spcPts val="1200"/>
+                        </a:spcAft>
+                        <a:buNone/>
+                      </a:pPr>
+                      <a:r>
+                        <a:rPr lang="nl-NL" sz="1000" spc="-10">
+                          <a:effectLst/>
+                        </a:rPr>
+                        <a:t>Vergelijken staging met target op basis van valide data</a:t>
+                      </a:r>
+                      <a:endParaRPr lang="en-NL" sz="1000" spc="-10">
+                        <a:solidFill>
+                          <a:srgbClr val="3B3B3B"/>
+                        </a:solidFill>
+                        <a:effectLst/>
+                        <a:latin typeface="Ubuntu Light" panose="020B0304030602030204" pitchFamily="34" charset="0"/>
+                        <a:ea typeface="Arial" panose="020B0604020202020204" pitchFamily="34" charset="0"/>
+                        <a:cs typeface="Times New Roman" panose="02020603050405020304" pitchFamily="18" charset="0"/>
+                      </a:endParaRPr>
+                    </a:p>
+                  </a:txBody>
+                  <a:tcPr marL="68580" marR="68580" marT="68580" marB="68580" anchor="ctr"/>
+                </a:tc>
+                <a:extLst>
+                  <a:ext uri="{0D108BD9-81ED-4DB2-BD59-A6C34878D82A}">
+                    <a16:rowId xmlns:a16="http://schemas.microsoft.com/office/drawing/2014/main" val="3603805790"/>
+                  </a:ext>
+                </a:extLst>
+              </a:tr>
+              <a:tr h="0">
+                <a:tc>
+                  <a:txBody>
+                    <a:bodyPr/>
+                    <a:lstStyle/>
+                    <a:p>
+                      <a:pPr algn="l">
+                        <a:lnSpc>
+                          <a:spcPct val="120000"/>
+                        </a:lnSpc>
+                        <a:spcAft>
+                          <a:spcPts val="1200"/>
+                        </a:spcAft>
+                        <a:buNone/>
+                      </a:pPr>
+                      <a:r>
+                        <a:rPr lang="nl-NL" sz="1000" spc="-10">
+                          <a:effectLst/>
+                        </a:rPr>
+                        <a:t>Uniqueness</a:t>
+                      </a:r>
+                      <a:endParaRPr lang="en-NL" sz="1000" spc="-10">
+                        <a:solidFill>
+                          <a:srgbClr val="3B3B3B"/>
+                        </a:solidFill>
+                        <a:effectLst/>
+                        <a:latin typeface="Ubuntu Light" panose="020B0304030602030204" pitchFamily="34" charset="0"/>
+                        <a:ea typeface="Arial" panose="020B0604020202020204" pitchFamily="34" charset="0"/>
+                        <a:cs typeface="Times New Roman" panose="02020603050405020304" pitchFamily="18" charset="0"/>
+                      </a:endParaRPr>
+                    </a:p>
+                  </a:txBody>
+                  <a:tcPr marL="68580" marR="68580" marT="68580" marB="68580" anchor="ctr"/>
+                </a:tc>
+                <a:tc>
+                  <a:txBody>
+                    <a:bodyPr/>
+                    <a:lstStyle/>
+                    <a:p>
+                      <a:pPr algn="l">
+                        <a:lnSpc>
+                          <a:spcPct val="120000"/>
+                        </a:lnSpc>
+                        <a:spcAft>
+                          <a:spcPts val="1200"/>
+                        </a:spcAft>
+                        <a:buNone/>
+                      </a:pPr>
+                      <a:r>
+                        <a:rPr lang="nl-NL" sz="1000" spc="-10">
+                          <a:effectLst/>
+                        </a:rPr>
+                        <a:t>Zijn er duplicaten?</a:t>
+                      </a:r>
+                      <a:endParaRPr lang="en-NL" sz="1000" spc="-10">
+                        <a:solidFill>
+                          <a:srgbClr val="3B3B3B"/>
+                        </a:solidFill>
+                        <a:effectLst/>
+                        <a:latin typeface="Ubuntu Light" panose="020B0304030602030204" pitchFamily="34" charset="0"/>
+                        <a:ea typeface="Arial" panose="020B0604020202020204" pitchFamily="34" charset="0"/>
+                        <a:cs typeface="Times New Roman" panose="02020603050405020304" pitchFamily="18" charset="0"/>
+                      </a:endParaRPr>
+                    </a:p>
+                  </a:txBody>
+                  <a:tcPr marL="68580" marR="68580" marT="68580" marB="68580" anchor="ctr"/>
+                </a:tc>
+                <a:tc>
+                  <a:txBody>
+                    <a:bodyPr/>
+                    <a:lstStyle/>
+                    <a:p>
+                      <a:pPr algn="l">
+                        <a:lnSpc>
+                          <a:spcPct val="120000"/>
+                        </a:lnSpc>
+                        <a:spcAft>
+                          <a:spcPts val="1200"/>
+                        </a:spcAft>
+                        <a:buNone/>
+                      </a:pPr>
+                      <a:r>
+                        <a:rPr lang="nl-NL" sz="1000" spc="-10">
+                          <a:effectLst/>
+                        </a:rPr>
+                        <a:t>Het detecteren van duplicaten is een kern functie van het component</a:t>
+                      </a:r>
+                      <a:endParaRPr lang="en-NL" sz="1000" spc="-10">
+                        <a:solidFill>
+                          <a:srgbClr val="3B3B3B"/>
+                        </a:solidFill>
+                        <a:effectLst/>
+                        <a:latin typeface="Ubuntu Light" panose="020B0304030602030204" pitchFamily="34" charset="0"/>
+                        <a:ea typeface="Arial" panose="020B0604020202020204" pitchFamily="34" charset="0"/>
+                        <a:cs typeface="Times New Roman" panose="02020603050405020304" pitchFamily="18" charset="0"/>
+                      </a:endParaRPr>
+                    </a:p>
+                  </a:txBody>
+                  <a:tcPr marL="68580" marR="68580" marT="68580" marB="68580" anchor="ctr"/>
+                </a:tc>
+                <a:tc>
+                  <a:txBody>
+                    <a:bodyPr/>
+                    <a:lstStyle/>
+                    <a:p>
+                      <a:pPr algn="l">
+                        <a:lnSpc>
+                          <a:spcPct val="120000"/>
+                        </a:lnSpc>
+                        <a:spcAft>
+                          <a:spcPts val="1200"/>
+                        </a:spcAft>
+                        <a:buNone/>
+                      </a:pPr>
+                      <a:r>
+                        <a:rPr lang="nl-NL" sz="1000" spc="-10">
+                          <a:effectLst/>
+                        </a:rPr>
+                        <a:t>Testcases met dubbele updates en dubbele inserts</a:t>
+                      </a:r>
+                      <a:endParaRPr lang="en-NL" sz="1000" spc="-10">
+                        <a:solidFill>
+                          <a:srgbClr val="3B3B3B"/>
+                        </a:solidFill>
+                        <a:effectLst/>
+                        <a:latin typeface="Ubuntu Light" panose="020B0304030602030204" pitchFamily="34" charset="0"/>
+                        <a:ea typeface="Arial" panose="020B0604020202020204" pitchFamily="34" charset="0"/>
+                        <a:cs typeface="Times New Roman" panose="02020603050405020304" pitchFamily="18" charset="0"/>
+                      </a:endParaRPr>
+                    </a:p>
+                  </a:txBody>
+                  <a:tcPr marL="68580" marR="68580" marT="68580" marB="68580" anchor="ctr"/>
+                </a:tc>
+                <a:extLst>
+                  <a:ext uri="{0D108BD9-81ED-4DB2-BD59-A6C34878D82A}">
+                    <a16:rowId xmlns:a16="http://schemas.microsoft.com/office/drawing/2014/main" val="303205083"/>
+                  </a:ext>
+                </a:extLst>
+              </a:tr>
+              <a:tr h="0">
+                <a:tc>
+                  <a:txBody>
+                    <a:bodyPr/>
+                    <a:lstStyle/>
+                    <a:p>
+                      <a:pPr algn="l">
+                        <a:lnSpc>
+                          <a:spcPct val="120000"/>
+                        </a:lnSpc>
+                        <a:spcAft>
+                          <a:spcPts val="1200"/>
+                        </a:spcAft>
+                        <a:buNone/>
+                      </a:pPr>
+                      <a:r>
+                        <a:rPr lang="nl-NL" sz="1000" spc="-10">
+                          <a:effectLst/>
+                        </a:rPr>
+                        <a:t>Consistency</a:t>
+                      </a:r>
+                      <a:endParaRPr lang="en-NL" sz="1000" spc="-10">
+                        <a:solidFill>
+                          <a:srgbClr val="3B3B3B"/>
+                        </a:solidFill>
+                        <a:effectLst/>
+                        <a:latin typeface="Ubuntu Light" panose="020B0304030602030204" pitchFamily="34" charset="0"/>
+                        <a:ea typeface="Arial" panose="020B0604020202020204" pitchFamily="34" charset="0"/>
+                        <a:cs typeface="Times New Roman" panose="02020603050405020304" pitchFamily="18" charset="0"/>
+                      </a:endParaRPr>
+                    </a:p>
+                  </a:txBody>
+                  <a:tcPr marL="68580" marR="68580" marT="68580" marB="68580" anchor="ctr"/>
+                </a:tc>
+                <a:tc>
+                  <a:txBody>
+                    <a:bodyPr/>
+                    <a:lstStyle/>
+                    <a:p>
+                      <a:pPr algn="l">
+                        <a:lnSpc>
+                          <a:spcPct val="120000"/>
+                        </a:lnSpc>
+                        <a:spcAft>
+                          <a:spcPts val="1200"/>
+                        </a:spcAft>
+                        <a:buNone/>
+                      </a:pPr>
+                      <a:r>
+                        <a:rPr lang="nl-NL" sz="1000" spc="-10">
+                          <a:effectLst/>
+                        </a:rPr>
+                        <a:t>Is data overal gelijk?</a:t>
+                      </a:r>
+                      <a:endParaRPr lang="en-NL" sz="1000" spc="-10">
+                        <a:solidFill>
+                          <a:srgbClr val="3B3B3B"/>
+                        </a:solidFill>
+                        <a:effectLst/>
+                        <a:latin typeface="Ubuntu Light" panose="020B0304030602030204" pitchFamily="34" charset="0"/>
+                        <a:ea typeface="Arial" panose="020B0604020202020204" pitchFamily="34" charset="0"/>
+                        <a:cs typeface="Times New Roman" panose="02020603050405020304" pitchFamily="18" charset="0"/>
+                      </a:endParaRPr>
+                    </a:p>
+                  </a:txBody>
+                  <a:tcPr marL="68580" marR="68580" marT="68580" marB="68580" anchor="ctr"/>
+                </a:tc>
+                <a:tc>
+                  <a:txBody>
+                    <a:bodyPr/>
+                    <a:lstStyle/>
+                    <a:p>
+                      <a:pPr algn="l">
+                        <a:lnSpc>
+                          <a:spcPct val="120000"/>
+                        </a:lnSpc>
+                        <a:spcAft>
+                          <a:spcPts val="1200"/>
+                        </a:spcAft>
+                        <a:buNone/>
+                      </a:pPr>
+                      <a:r>
+                        <a:rPr lang="nl-NL" sz="1000" spc="-10">
+                          <a:effectLst/>
+                        </a:rPr>
+                        <a:t>Data in staging en target moet overeenkomen als er geen wijzigingen zijn</a:t>
+                      </a:r>
+                      <a:endParaRPr lang="en-NL" sz="1000" spc="-10">
+                        <a:solidFill>
+                          <a:srgbClr val="3B3B3B"/>
+                        </a:solidFill>
+                        <a:effectLst/>
+                        <a:latin typeface="Ubuntu Light" panose="020B0304030602030204" pitchFamily="34" charset="0"/>
+                        <a:ea typeface="Arial" panose="020B0604020202020204" pitchFamily="34" charset="0"/>
+                        <a:cs typeface="Times New Roman" panose="02020603050405020304" pitchFamily="18" charset="0"/>
+                      </a:endParaRPr>
+                    </a:p>
+                  </a:txBody>
+                  <a:tcPr marL="68580" marR="68580" marT="68580" marB="68580" anchor="ctr"/>
+                </a:tc>
+                <a:tc>
+                  <a:txBody>
+                    <a:bodyPr/>
+                    <a:lstStyle/>
+                    <a:p>
+                      <a:pPr algn="l">
+                        <a:lnSpc>
+                          <a:spcPct val="120000"/>
+                        </a:lnSpc>
+                        <a:spcAft>
+                          <a:spcPts val="1200"/>
+                        </a:spcAft>
+                        <a:buNone/>
+                      </a:pPr>
+                      <a:r>
+                        <a:rPr lang="nl-NL" sz="1000" spc="-10" dirty="0">
+                          <a:effectLst/>
+                        </a:rPr>
+                        <a:t>Vergelijken van hashwaarden en kolommen tussen tabellen</a:t>
+                      </a:r>
+                      <a:endParaRPr lang="en-NL" sz="1000" spc="-10" dirty="0">
+                        <a:solidFill>
+                          <a:srgbClr val="3B3B3B"/>
+                        </a:solidFill>
+                        <a:effectLst/>
+                        <a:latin typeface="Ubuntu Light" panose="020B0304030602030204" pitchFamily="34" charset="0"/>
+                        <a:ea typeface="Arial" panose="020B0604020202020204" pitchFamily="34" charset="0"/>
+                        <a:cs typeface="Times New Roman" panose="02020603050405020304" pitchFamily="18" charset="0"/>
+                      </a:endParaRPr>
+                    </a:p>
+                  </a:txBody>
+                  <a:tcPr marL="68580" marR="68580" marT="68580" marB="68580" anchor="ctr"/>
+                </a:tc>
+                <a:extLst>
+                  <a:ext uri="{0D108BD9-81ED-4DB2-BD59-A6C34878D82A}">
+                    <a16:rowId xmlns:a16="http://schemas.microsoft.com/office/drawing/2014/main" val="270693898"/>
+                  </a:ext>
+                </a:extLst>
+              </a:tr>
+            </a:tbl>
+          </a:graphicData>
+        </a:graphic>
+      </p:graphicFrame>
     </p:spTree>
     <p:extLst>
       <p:ext uri="{BB962C8B-B14F-4D97-AF65-F5344CB8AC3E}">

</xml_diff>